<commit_message>
Correct the benchmark figures, the leaked stage labels and the reference list
ChinaTravel reports 37.0% constraint satisfaction against 2.6% purely neural (Shao et al., ICLR 2026); the ~97% figure is Hao et al. (NAACL 2025) on TravelPlanner, where GPT-4 scores 0.6% (Xie et al., ICML 2024). All four numbers verified against the papers. Slide 7 was rendering a function repr where the stage labels belong; the builder now asserts no leaked value survives. IndicTrans2 and Dijkstra are dropped from the references because neither runs in the system. Demo port moves to 8080.
</commit_message>
<xml_diff>
--- a/docs/review1/Travel_Yantra_Phase2_Review1.pptx
+++ b/docs/review1/Travel_Yantra_Phase2_Review1.pptx
@@ -19133,7 +19133,7 @@
                 <a:cs typeface="Times New Roman" panose="02020603050405020304" pitchFamily="18" charset="0"/>
                 <a:sym typeface="Bookman Old Style"/>
               </a:rPr>
-              <a:t>Modelled on ChinaTravel (ICLR 2026), which built the equivalent benchmark for Chinese travel and showed that a language model paired with a solver reaches roughly ninety-seven percent where a single model reaches about one percent.</a:t>
+              <a:t>Modelled on ChinaTravel (Shao et al., ICLR 2026), the equivalent open-ended benchmark for Chinese travel, on which neuro-symbolic agents reach 37.0 percent constraint satisfaction against 2.6 percent for purely neural ones — roughly a tenfold gap.</a:t>
             </a:r>
             <a:endParaRPr sz="1800" b="0" dirty="0">
               <a:latin typeface="Times New Roman" panose="02020603050405020304" pitchFamily="18" charset="0"/>
@@ -20224,7 +20224,7 @@
         </p:nvSpPr>
         <p:spPr>
           <a:xfrm>
-            <a:off x="4892040" y="1463040"/>
+            <a:off x="4892040" y="1444752"/>
             <a:ext cx="3749039" cy="228600"/>
           </a:xfrm>
           <a:prstGeom prst="rect">
@@ -20260,7 +20260,7 @@
         <p:spPr>
           <a:xfrm>
             <a:off x="4892040" y="1755648"/>
-            <a:ext cx="3749039" cy="274320"/>
+            <a:ext cx="3749039" cy="219456"/>
           </a:xfrm>
           <a:prstGeom prst="rect">
             <a:avLst/>
@@ -20275,13 +20275,13 @@
           <a:p>
             <a:pPr algn="l"/>
             <a:r>
-              <a:rPr sz="950" b="0" i="0">
-                <a:solidFill>
-                  <a:srgbClr val="333333"/>
+              <a:rPr sz="850" b="0" i="1">
+                <a:solidFill>
+                  <a:srgbClr val="7A7A7A"/>
                 </a:solidFill>
                 <a:latin typeface="Times New Roman"/>
               </a:rPr>
-              <a:t>Final pass rate on multi-constraint travel planning</a:t>
+              <a:t>TravelPlanner (Xie et al., ICML 2024) — final pass rate [1]</a:t>
             </a:r>
           </a:p>
         </p:txBody>
@@ -20294,8 +20294,8 @@
         </p:nvSpPr>
         <p:spPr>
           <a:xfrm>
-            <a:off x="4892040" y="2084831"/>
-            <a:ext cx="274320" cy="310896"/>
+            <a:off x="6144768" y="1993391"/>
+            <a:ext cx="45720" cy="237744"/>
           </a:xfrm>
           <a:prstGeom prst="rect">
             <a:avLst/>
@@ -20347,8 +20347,8 @@
         </p:nvSpPr>
         <p:spPr>
           <a:xfrm>
-            <a:off x="5230368" y="2112264"/>
-            <a:ext cx="3291840" cy="274320"/>
+            <a:off x="4892040" y="2011679"/>
+            <a:ext cx="1188720" cy="219456"/>
           </a:xfrm>
           <a:prstGeom prst="rect">
             <a:avLst/>
@@ -20361,15 +20361,15 @@
           </a:bodyPr>
           <a:lstStyle/>
           <a:p>
-            <a:pPr algn="l"/>
+            <a:pPr algn="r"/>
             <a:r>
-              <a:rPr sz="1000" b="1" i="0">
+              <a:rPr sz="900" b="0" i="0">
                 <a:solidFill>
                   <a:srgbClr val="000000"/>
                 </a:solidFill>
                 <a:latin typeface="Times New Roman"/>
               </a:rPr>
-              <a:t>~1%   Single LLM agent (GPT-4)</a:t>
+              <a:t>GPT-4-Turbo</a:t>
             </a:r>
           </a:p>
         </p:txBody>
@@ -20382,8 +20382,8 @@
         </p:nvSpPr>
         <p:spPr>
           <a:xfrm>
-            <a:off x="4892040" y="2432304"/>
-            <a:ext cx="3749039" cy="228600"/>
+            <a:off x="6254496" y="2002535"/>
+            <a:ext cx="914400" cy="219456"/>
           </a:xfrm>
           <a:prstGeom prst="rect">
             <a:avLst/>
@@ -20398,13 +20398,13 @@
           <a:p>
             <a:pPr algn="l"/>
             <a:r>
-              <a:rPr sz="850" b="0" i="1">
-                <a:solidFill>
-                  <a:srgbClr val="7A7A7A"/>
+              <a:rPr sz="950" b="1" i="0">
+                <a:solidFill>
+                  <a:srgbClr val="000000"/>
                 </a:solidFill>
                 <a:latin typeface="Times New Roman"/>
               </a:rPr>
-              <a:t>TravelPlanner, Xie et al., 2024 [1]</a:t>
+              <a:t>0.6%</a:t>
             </a:r>
           </a:p>
         </p:txBody>
@@ -20417,8 +20417,8 @@
         </p:nvSpPr>
         <p:spPr>
           <a:xfrm>
-            <a:off x="4892040" y="2761488"/>
-            <a:ext cx="3246120" cy="310896"/>
+            <a:off x="6144768" y="2313432"/>
+            <a:ext cx="2173071" cy="237744"/>
           </a:xfrm>
           <a:prstGeom prst="rect">
             <a:avLst/>
@@ -20457,7 +20457,7 @@
                 </a:solidFill>
                 <a:latin typeface="Times New Roman"/>
               </a:rPr>
-              <a:t>~97%</a:t>
+              <a:t/>
             </a:r>
           </a:p>
         </p:txBody>
@@ -20470,8 +20470,8 @@
         </p:nvSpPr>
         <p:spPr>
           <a:xfrm>
-            <a:off x="4892040" y="3127248"/>
-            <a:ext cx="3749039" cy="228600"/>
+            <a:off x="4892040" y="2331720"/>
+            <a:ext cx="1188720" cy="219456"/>
           </a:xfrm>
           <a:prstGeom prst="rect">
             <a:avLst/>
@@ -20484,15 +20484,15 @@
           </a:bodyPr>
           <a:lstStyle/>
           <a:p>
-            <a:pPr algn="l"/>
+            <a:pPr algn="r"/>
             <a:r>
-              <a:rPr sz="850" b="0" i="1">
-                <a:solidFill>
-                  <a:srgbClr val="7A7A7A"/>
+              <a:rPr sz="900" b="0" i="0">
+                <a:solidFill>
+                  <a:srgbClr val="000000"/>
                 </a:solidFill>
                 <a:latin typeface="Times New Roman"/>
               </a:rPr>
-              <a:t>LLM paired with a solver — ChinaTravel, ICLR 2026 [2]</a:t>
+              <a:t>LLM + SMT solver [2]</a:t>
             </a:r>
           </a:p>
         </p:txBody>
@@ -20505,8 +20505,8 @@
         </p:nvSpPr>
         <p:spPr>
           <a:xfrm>
-            <a:off x="4892040" y="3474720"/>
-            <a:ext cx="3749039" cy="1737360"/>
+            <a:off x="8381847" y="2322575"/>
+            <a:ext cx="914400" cy="219456"/>
           </a:xfrm>
           <a:prstGeom prst="rect">
             <a:avLst/>
@@ -20521,37 +20521,364 @@
           <a:p>
             <a:pPr algn="l"/>
             <a:r>
-              <a:rPr sz="1050" b="0" i="0">
+              <a:rPr sz="950" b="1" i="0">
                 <a:solidFill>
                   <a:srgbClr val="000000"/>
                 </a:solidFill>
                 <a:latin typeface="Times New Roman"/>
               </a:rPr>
-              <a:t>Both figures are as reported by those papers. They are the reason the planner in this project is a solver and the model is kept out of the decision: the failure mode being avoided is measured, not assumed.</a:t>
+              <a:t>97%</a:t>
             </a:r>
           </a:p>
+        </p:txBody>
+      </p:sp>
+      <p:sp>
+        <p:nvSpPr>
+          <p:cNvPr id="162" name="TextBox 161"/>
+          <p:cNvSpPr txBox="1"/>
+          <p:nvPr/>
+        </p:nvSpPr>
+        <p:spPr>
+          <a:xfrm>
+            <a:off x="4892040" y="2724912"/>
+            <a:ext cx="3749039" cy="219456"/>
+          </a:xfrm>
+          <a:prstGeom prst="rect">
+            <a:avLst/>
+          </a:prstGeom>
+          <a:noFill/>
+        </p:spPr>
+        <p:txBody>
+          <a:bodyPr wrap="square" lIns="0" rIns="0" tIns="0" bIns="0">
+            <a:spAutoFit/>
+          </a:bodyPr>
+          <a:lstStyle/>
           <a:p>
             <a:pPr algn="l"/>
             <a:r>
-              <a:rPr sz="1050" b="0" i="0">
-                <a:solidFill>
-                  <a:srgbClr val="000000"/>
+              <a:rPr sz="850" b="0" i="1">
+                <a:solidFill>
+                  <a:srgbClr val="7A7A7A"/>
+                </a:solidFill>
+                <a:latin typeface="Times New Roman"/>
+              </a:rPr>
+              <a:t>ChinaTravel (Shao et al., ICLR 2026) — constraint satisfaction [3]</a:t>
+            </a:r>
+          </a:p>
+        </p:txBody>
+      </p:sp>
+      <p:sp>
+        <p:nvSpPr>
+          <p:cNvPr id="163" name="Rectangle 162"/>
+          <p:cNvSpPr/>
+          <p:nvPr/>
+        </p:nvSpPr>
+        <p:spPr>
+          <a:xfrm>
+            <a:off x="6144768" y="2962656"/>
+            <a:ext cx="58247" cy="237744"/>
+          </a:xfrm>
+          <a:prstGeom prst="rect">
+            <a:avLst/>
+          </a:prstGeom>
+          <a:solidFill>
+            <a:srgbClr val="D1282E"/>
+          </a:solidFill>
+          <a:ln>
+            <a:noFill/>
+          </a:ln>
+          <a:effectLst/>
+        </p:spPr>
+        <p:style>
+          <a:lnRef idx="1">
+            <a:schemeClr val="accent1"/>
+          </a:lnRef>
+          <a:fillRef idx="3">
+            <a:schemeClr val="accent1"/>
+          </a:fillRef>
+          <a:effectRef idx="2">
+            <a:schemeClr val="accent1"/>
+          </a:effectRef>
+          <a:fontRef idx="minor">
+            <a:schemeClr val="lt1"/>
+          </a:fontRef>
+        </p:style>
+        <p:txBody>
+          <a:bodyPr rtlCol="0" anchor="ctr" lIns="36000" rIns="36000"/>
+          <a:lstStyle/>
+          <a:p>
+            <a:pPr algn="r"/>
+            <a:r>
+              <a:rPr sz="900" b="1">
+                <a:solidFill>
+                  <a:srgbClr val="FFFFFF"/>
                 </a:solidFill>
                 <a:latin typeface="Times New Roman"/>
               </a:rPr>
               <a:t/>
             </a:r>
           </a:p>
+        </p:txBody>
+      </p:sp>
+      <p:sp>
+        <p:nvSpPr>
+          <p:cNvPr id="164" name="TextBox 163"/>
+          <p:cNvSpPr txBox="1"/>
+          <p:nvPr/>
+        </p:nvSpPr>
+        <p:spPr>
+          <a:xfrm>
+            <a:off x="4892040" y="2980944"/>
+            <a:ext cx="1188720" cy="219456"/>
+          </a:xfrm>
+          <a:prstGeom prst="rect">
+            <a:avLst/>
+          </a:prstGeom>
+          <a:noFill/>
+        </p:spPr>
+        <p:txBody>
+          <a:bodyPr wrap="square" lIns="0" rIns="0" tIns="0" bIns="0">
+            <a:spAutoFit/>
+          </a:bodyPr>
+          <a:lstStyle/>
+          <a:p>
+            <a:pPr algn="r"/>
+            <a:r>
+              <a:rPr sz="900" b="0" i="0">
+                <a:solidFill>
+                  <a:srgbClr val="000000"/>
+                </a:solidFill>
+                <a:latin typeface="Times New Roman"/>
+              </a:rPr>
+              <a:t>Purely neural</a:t>
+            </a:r>
+          </a:p>
+        </p:txBody>
+      </p:sp>
+      <p:sp>
+        <p:nvSpPr>
+          <p:cNvPr id="165" name="TextBox 164"/>
+          <p:cNvSpPr txBox="1"/>
+          <p:nvPr/>
+        </p:nvSpPr>
+        <p:spPr>
+          <a:xfrm>
+            <a:off x="6267023" y="2971800"/>
+            <a:ext cx="914400" cy="219456"/>
+          </a:xfrm>
+          <a:prstGeom prst="rect">
+            <a:avLst/>
+          </a:prstGeom>
+          <a:noFill/>
+        </p:spPr>
+        <p:txBody>
+          <a:bodyPr wrap="square" lIns="0" rIns="0" tIns="0" bIns="0">
+            <a:spAutoFit/>
+          </a:bodyPr>
+          <a:lstStyle/>
           <a:p>
             <a:pPr algn="l"/>
             <a:r>
-              <a:rPr sz="1050" b="0" i="0">
+              <a:rPr sz="950" b="1" i="0">
                 <a:solidFill>
                   <a:srgbClr val="000000"/>
                 </a:solidFill>
                 <a:latin typeface="Times New Roman"/>
               </a:rPr>
-              <a:t>Our own constraint result on the demonstration trip — 37 of 37 checks passed — is reported on the results slide.</a:t>
+              <a:t>2.6%</a:t>
+            </a:r>
+          </a:p>
+        </p:txBody>
+      </p:sp>
+      <p:sp>
+        <p:nvSpPr>
+          <p:cNvPr id="166" name="Rectangle 165"/>
+          <p:cNvSpPr/>
+          <p:nvPr/>
+        </p:nvSpPr>
+        <p:spPr>
+          <a:xfrm>
+            <a:off x="6144768" y="3282696"/>
+            <a:ext cx="828903" cy="237744"/>
+          </a:xfrm>
+          <a:prstGeom prst="rect">
+            <a:avLst/>
+          </a:prstGeom>
+          <a:solidFill>
+            <a:srgbClr val="526DB0"/>
+          </a:solidFill>
+          <a:ln>
+            <a:noFill/>
+          </a:ln>
+          <a:effectLst/>
+        </p:spPr>
+        <p:style>
+          <a:lnRef idx="1">
+            <a:schemeClr val="accent1"/>
+          </a:lnRef>
+          <a:fillRef idx="3">
+            <a:schemeClr val="accent1"/>
+          </a:fillRef>
+          <a:effectRef idx="2">
+            <a:schemeClr val="accent1"/>
+          </a:effectRef>
+          <a:fontRef idx="minor">
+            <a:schemeClr val="lt1"/>
+          </a:fontRef>
+        </p:style>
+        <p:txBody>
+          <a:bodyPr rtlCol="0" anchor="ctr" lIns="36000" rIns="36000"/>
+          <a:lstStyle/>
+          <a:p>
+            <a:pPr algn="r"/>
+            <a:r>
+              <a:rPr sz="900" b="1">
+                <a:solidFill>
+                  <a:srgbClr val="FFFFFF"/>
+                </a:solidFill>
+                <a:latin typeface="Times New Roman"/>
+              </a:rPr>
+              <a:t/>
+            </a:r>
+          </a:p>
+        </p:txBody>
+      </p:sp>
+      <p:sp>
+        <p:nvSpPr>
+          <p:cNvPr id="167" name="TextBox 166"/>
+          <p:cNvSpPr txBox="1"/>
+          <p:nvPr/>
+        </p:nvSpPr>
+        <p:spPr>
+          <a:xfrm>
+            <a:off x="4892040" y="3300984"/>
+            <a:ext cx="1188720" cy="219456"/>
+          </a:xfrm>
+          <a:prstGeom prst="rect">
+            <a:avLst/>
+          </a:prstGeom>
+          <a:noFill/>
+        </p:spPr>
+        <p:txBody>
+          <a:bodyPr wrap="square" lIns="0" rIns="0" tIns="0" bIns="0">
+            <a:spAutoFit/>
+          </a:bodyPr>
+          <a:lstStyle/>
+          <a:p>
+            <a:pPr algn="r"/>
+            <a:r>
+              <a:rPr sz="900" b="0" i="0">
+                <a:solidFill>
+                  <a:srgbClr val="000000"/>
+                </a:solidFill>
+                <a:latin typeface="Times New Roman"/>
+              </a:rPr>
+              <a:t>Neuro-symbolic</a:t>
+            </a:r>
+          </a:p>
+        </p:txBody>
+      </p:sp>
+      <p:sp>
+        <p:nvSpPr>
+          <p:cNvPr id="168" name="TextBox 167"/>
+          <p:cNvSpPr txBox="1"/>
+          <p:nvPr/>
+        </p:nvSpPr>
+        <p:spPr>
+          <a:xfrm>
+            <a:off x="7037679" y="3291840"/>
+            <a:ext cx="914400" cy="219456"/>
+          </a:xfrm>
+          <a:prstGeom prst="rect">
+            <a:avLst/>
+          </a:prstGeom>
+          <a:noFill/>
+        </p:spPr>
+        <p:txBody>
+          <a:bodyPr wrap="square" lIns="0" rIns="0" tIns="0" bIns="0">
+            <a:spAutoFit/>
+          </a:bodyPr>
+          <a:lstStyle/>
+          <a:p>
+            <a:pPr algn="l"/>
+            <a:r>
+              <a:rPr sz="950" b="1" i="0">
+                <a:solidFill>
+                  <a:srgbClr val="000000"/>
+                </a:solidFill>
+                <a:latin typeface="Times New Roman"/>
+              </a:rPr>
+              <a:t>37%</a:t>
+            </a:r>
+          </a:p>
+        </p:txBody>
+      </p:sp>
+      <p:sp>
+        <p:nvSpPr>
+          <p:cNvPr id="169" name="TextBox 168"/>
+          <p:cNvSpPr txBox="1"/>
+          <p:nvPr/>
+        </p:nvSpPr>
+        <p:spPr>
+          <a:xfrm>
+            <a:off x="4892040" y="3675887"/>
+            <a:ext cx="3749039" cy="1371600"/>
+          </a:xfrm>
+          <a:prstGeom prst="rect">
+            <a:avLst/>
+          </a:prstGeom>
+          <a:noFill/>
+        </p:spPr>
+        <p:txBody>
+          <a:bodyPr wrap="square" lIns="0" rIns="0" tIns="0" bIns="0">
+            <a:spAutoFit/>
+          </a:bodyPr>
+          <a:lstStyle/>
+          <a:p>
+            <a:pPr algn="l"/>
+            <a:r>
+              <a:rPr sz="1000" b="0" i="0">
+                <a:solidFill>
+                  <a:srgbClr val="000000"/>
+                </a:solidFill>
+                <a:latin typeface="Times New Roman"/>
+              </a:rPr>
+              <a:t>Pure language-model agents score in the low single digits on both benchmarks. Pairing the model with a solver raises that by more than an order of magnitude on both. These are the published figures, not ours, and they are why the planner here is a solver and the model is kept out of the decision.</a:t>
+            </a:r>
+          </a:p>
+        </p:txBody>
+      </p:sp>
+      <p:sp>
+        <p:nvSpPr>
+          <p:cNvPr id="170" name="TextBox 169"/>
+          <p:cNvSpPr txBox="1"/>
+          <p:nvPr/>
+        </p:nvSpPr>
+        <p:spPr>
+          <a:xfrm>
+            <a:off x="4892040" y="5029200"/>
+            <a:ext cx="3749039" cy="548640"/>
+          </a:xfrm>
+          <a:prstGeom prst="rect">
+            <a:avLst/>
+          </a:prstGeom>
+          <a:noFill/>
+        </p:spPr>
+        <p:txBody>
+          <a:bodyPr wrap="square" lIns="0" rIns="0" tIns="0" bIns="0">
+            <a:spAutoFit/>
+          </a:bodyPr>
+          <a:lstStyle/>
+          <a:p>
+            <a:pPr algn="l"/>
+            <a:r>
+              <a:rPr sz="1000" b="1" i="0">
+                <a:solidFill>
+                  <a:srgbClr val="000000"/>
+                </a:solidFill>
+                <a:latin typeface="Times New Roman"/>
+              </a:rPr>
+              <a:t>Our own constraint result on the demonstration trip — 37 of 37 checks passed — is on the results slide.</a:t>
             </a:r>
           </a:p>
         </p:txBody>
@@ -22267,7 +22594,7 @@
                 <a:cs typeface="Times New Roman" panose="02020603050405020304" pitchFamily="18" charset="0"/>
                 <a:sym typeface="Bookman Old Style"/>
               </a:rPr>
-              <a:t>[2] X.-Y. Shao et al., “ChinaTravel: A Real-World Benchmark for Language Agents in Chinese Travel Planning,” in Proc. Int. Conf. Learning Representations (ICLR), 2026.</a:t>
+              <a:t>[2] Y. Hao, Y. Chen, Y. Zhang and C. Fan, “Large Language Models Can Solve Real-World Planning Rigorously with Formal Verification Tools,” in Proc. 2025 Conf. North American Chapter of the ACL (NAACL), 2025, pp. 3499–3557.</a:t>
             </a:r>
             <a:endParaRPr sz="1800" b="0" dirty="0">
               <a:latin typeface="Times New Roman" panose="02020603050405020304" pitchFamily="18" charset="0"/>
@@ -22299,7 +22626,7 @@
                 <a:cs typeface="Times New Roman" panose="02020603050405020304" pitchFamily="18" charset="0"/>
                 <a:sym typeface="Bookman Old Style"/>
               </a:rPr>
-              <a:t>[3] P. Lewis et al., “Retrieval-Augmented Generation for Knowledge-Intensive NLP Tasks,” in Adv. Neural Inf. Process. Syst. (NeurIPS), vol. 33, 2020, pp. 9459–9474.</a:t>
+              <a:t>[3] J.-J. Shao, B.-W. Zhang, X.-W. Yang, B. Chen, L.-Z. Guo and Y.-F. Li, “ChinaTravel: An Open-Ended Travel Planning Benchmark with Compositional Constraint Validation for Language Agents,” in Proc. Int. Conf. Learning Representations (ICLR), 2026.</a:t>
             </a:r>
             <a:endParaRPr sz="1800" b="0" dirty="0">
               <a:latin typeface="Times New Roman" panose="02020603050405020304" pitchFamily="18" charset="0"/>
@@ -22331,7 +22658,7 @@
                 <a:cs typeface="Times New Roman" panose="02020603050405020304" pitchFamily="18" charset="0"/>
                 <a:sym typeface="Bookman Old Style"/>
               </a:rPr>
-              <a:t>[4] J. Gala et al., “IndicTrans2: Towards High-Quality and Accessible Machine Translation Models for all 22 Scheduled Indian Languages,” Trans. Machine Learning Research, 2023.</a:t>
+              <a:t>[4] P. Lewis et al., “Retrieval-Augmented Generation for Knowledge-Intensive NLP Tasks,” in Adv. Neural Inf. Process. Syst. (NeurIPS), vol. 33, 2020, pp. 9459–9474.</a:t>
             </a:r>
             <a:endParaRPr sz="1800" b="0" dirty="0">
               <a:latin typeface="Times New Roman" panose="02020603050405020304" pitchFamily="18" charset="0"/>
@@ -22492,38 +22819,6 @@
                 <a:sym typeface="Bookman Old Style"/>
               </a:rPr>
               <a:t>[9] S. P. Lloyd, “Least Squares Quantization in PCM,” IEEE Trans. Information Theory, vol. 28, no. 2, pp. 129–137, 1982.</a:t>
-            </a:r>
-            <a:endParaRPr sz="1800" b="0" dirty="0">
-              <a:latin typeface="Times New Roman" panose="02020603050405020304" pitchFamily="18" charset="0"/>
-              <a:cs typeface="Times New Roman" panose="02020603050405020304" pitchFamily="18" charset="0"/>
-            </a:endParaRPr>
-          </a:p>
-          <a:p>
-            <a:pPr marL="228600" indent="0" algn="l" rtl="0">
-              <a:lnSpc>
-                <a:spcPct val="150000"/>
-              </a:lnSpc>
-              <a:spcBef>
-                <a:spcPts val="360"/>
-              </a:spcBef>
-              <a:spcAft>
-                <a:spcPts val="400"/>
-              </a:spcAft>
-              <a:buClr>
-                <a:schemeClr val="dk1"/>
-              </a:buClr>
-              <a:buSzPct val="90000"/>
-              <a:buFont typeface="Arial"/>
-              <a:buNone/>
-            </a:pPr>
-            <a:r>
-              <a:rPr lang="en-IN" sz="1000" b="0" dirty="0">
-                <a:latin typeface="Times New Roman" panose="02020603050405020304" pitchFamily="18" charset="0"/>
-                <a:ea typeface="Bookman Old Style"/>
-                <a:cs typeface="Times New Roman" panose="02020603050405020304" pitchFamily="18" charset="0"/>
-                <a:sym typeface="Bookman Old Style"/>
-              </a:rPr>
-              <a:t>[10] E. W. Dijkstra, “A Note on Two Problems in Connexion with Graphs,” Numerische Mathematik, vol. 1, pp. 269–271, 1959.</a:t>
             </a:r>
             <a:endParaRPr sz="1800" b="0" dirty="0">
               <a:latin typeface="Times New Roman" panose="02020603050405020304" pitchFamily="18" charset="0"/>
@@ -23270,7 +23565,7 @@
                 <a:cs typeface="Times New Roman"/>
                 <a:sym typeface="Times New Roman"/>
               </a:rPr>
-              <a:t>Problem Identified: Generic large language models are fluent but unreliable planners — under one percent of multi-constraint plans pass on the TravelPlanner benchmark — and free-form generation invents opening hours, fees and history that a traveller cannot check.</a:t>
+              <a:t>Problem Identified: Generic large language models are fluent but unreliable planners — GPT-4 passes 0.6 percent of multi-constraint plans on the TravelPlanner benchmark — and free-form generation invents opening hours, fees and history that a traveller cannot check.</a:t>
             </a:r>
             <a:endParaRPr sz="1600" b="0" dirty="0">
               <a:latin typeface="Times New Roman"/>
@@ -23689,7 +23984,7 @@
                 <a:cs typeface="Times New Roman" panose="02020603050405020304" pitchFamily="18" charset="0"/>
                 <a:sym typeface="Roboto"/>
               </a:rPr>
-              <a:t>Related work in one line: TravelPlanner (Xie et al., 2024) showed that a single language model fails multi-constraint travel planning; ChinaTravel (ICLR 2026) showed that pairing a language model with a solver recovers the accuracy. Our architecture follows that finding rather than restating the problem.</a:t>
+              <a:t>Related work in one line: TravelPlanner (Xie et al., ICML 2024) showed that a single language model fails multi-constraint travel planning; Hao et al. (NAACL 2025) recovered the accuracy on that same benchmark by handing the constraints to a solver; and ChinaTravel (Shao et al., ICLR 2026) reproduced the effect on a second, harder benchmark. Our architecture follows that finding rather than restating the problem.</a:t>
             </a:r>
             <a:endParaRPr sz="2100" b="0" dirty="0">
               <a:latin typeface="Times New Roman" panose="02020603050405020304" pitchFamily="18" charset="0"/>
@@ -23922,7 +24217,7 @@
                 <a:cs typeface="Times New Roman" panose="02020603050405020304" pitchFamily="18" charset="0"/>
                 <a:sym typeface="Roboto"/>
               </a:rPr>
-              <a:t>Booking and review platforms each solve one slice — flights, hotels, reviews, maps — and leave the traveller to be the integration layer. None of them sequence a day against opening hours.</a:t>
+              <a:t>Booking and review platforms each solve one slice — flights, hotels, reviews, maps — and leave the traveller to be the integration layer. Not one of them sequences a day against opening hours.</a:t>
             </a:r>
             <a:endParaRPr sz="2200" b="0" dirty="0">
               <a:latin typeface="Times New Roman" panose="02020603050405020304" pitchFamily="18" charset="0"/>
@@ -23953,7 +24248,7 @@
                 <a:cs typeface="Times New Roman" panose="02020603050405020304" pitchFamily="18" charset="0"/>
                 <a:sym typeface="Roboto"/>
               </a:rPr>
-              <a:t>General-purpose chat models are fluent but measured to pass under one percent of multi-constraint travel plans, and they state fees and timings with a confidence they have not earned.</a:t>
+              <a:t>General-purpose chat models are fluent, but measured at a 0.6 percent pass rate on multi-constraint travel plans, and they state fees and timings with a confidence they have not earned.</a:t>
             </a:r>
             <a:endParaRPr sz="2200" b="0" dirty="0">
               <a:latin typeface="Times New Roman" panose="02020603050405020304" pitchFamily="18" charset="0"/>
@@ -24862,7 +25157,7 @@
                 </a:solidFill>
                 <a:latin typeface="Times New Roman"/>
               </a:rPr>
-              <a:t>&lt;function head at 0x00000206B287EB60&gt;</a:t>
+              <a:t>1 Intake</a:t>
             </a:r>
           </a:p>
           <a:p>
@@ -24977,7 +25272,7 @@
                 </a:solidFill>
                 <a:latin typeface="Times New Roman"/>
               </a:rPr>
-              <a:t>&lt;function head at 0x00000206B287EB60&gt;</a:t>
+              <a:t>2 Candidates</a:t>
             </a:r>
           </a:p>
           <a:p>
@@ -25092,7 +25387,7 @@
                 </a:solidFill>
                 <a:latin typeface="Times New Roman"/>
               </a:rPr>
-              <a:t>&lt;function head at 0x00000206B287EB60&gt;</a:t>
+              <a:t>3 Cluster</a:t>
             </a:r>
           </a:p>
           <a:p>
@@ -25207,7 +25502,7 @@
                 </a:solidFill>
                 <a:latin typeface="Times New Roman"/>
               </a:rPr>
-              <a:t>&lt;function head at 0x00000206B287EB60&gt;</a:t>
+              <a:t>4 Route</a:t>
             </a:r>
           </a:p>
           <a:p>
@@ -25394,7 +25689,7 @@
                 </a:solidFill>
                 <a:latin typeface="Times New Roman"/>
               </a:rPr>
-              <a:t>&lt;function head at 0x00000206B287EB60&gt;</a:t>
+              <a:t>5 Validate</a:t>
             </a:r>
           </a:p>
           <a:p>
@@ -25509,7 +25804,7 @@
                 </a:solidFill>
                 <a:latin typeface="Times New Roman"/>
               </a:rPr>
-              <a:t>&lt;function head at 0x00000206B287EB60&gt;</a:t>
+              <a:t>6 Repair</a:t>
             </a:r>
           </a:p>
           <a:p>
@@ -25624,7 +25919,7 @@
                 </a:solidFill>
                 <a:latin typeface="Times New Roman"/>
               </a:rPr>
-              <a:t>&lt;function head at 0x00000206B287EB60&gt;</a:t>
+              <a:t>7 Reasons</a:t>
             </a:r>
           </a:p>
           <a:p>
@@ -25739,7 +26034,7 @@
                 </a:solidFill>
                 <a:latin typeface="Times New Roman"/>
               </a:rPr>
-              <a:t>&lt;function head at 0x00000206B287EB60&gt;</a:t>
+              <a:t>8 Narrate</a:t>
             </a:r>
           </a:p>
           <a:p>

</xml_diff>